<commit_message>
Update hackathon presentation; ignore brand manual scratch files
</commit_message>
<xml_diff>
--- a/presentation/260603 - Scenario Planner Hackathon.pptx
+++ b/presentation/260603 - Scenario Planner Hackathon.pptx
@@ -5,7 +5,7 @@
     <p:sldMasterId id="2147483652" r:id="rId1"/>
   </p:sldMasterIdLst>
   <p:notesMasterIdLst>
-    <p:notesMasterId r:id="rId15"/>
+    <p:notesMasterId r:id="rId7"/>
   </p:notesMasterIdLst>
   <p:sldIdLst>
     <p:sldId id="256" r:id="rId2"/>
@@ -13,14 +13,6 @@
     <p:sldId id="269" r:id="rId4"/>
     <p:sldId id="270" r:id="rId5"/>
     <p:sldId id="265" r:id="rId6"/>
-    <p:sldId id="267" r:id="rId7"/>
-    <p:sldId id="268" r:id="rId8"/>
-    <p:sldId id="261" r:id="rId9"/>
-    <p:sldId id="266" r:id="rId10"/>
-    <p:sldId id="258" r:id="rId11"/>
-    <p:sldId id="259" r:id="rId12"/>
-    <p:sldId id="263" r:id="rId13"/>
-    <p:sldId id="260" r:id="rId14"/>
   </p:sldIdLst>
   <p:sldSz cx="12192000" cy="6858000"/>
   <p:notesSz cx="6858000" cy="9144000"/>
@@ -2676,7 +2668,7 @@
           <a:p>
             <a:r>
               <a:rPr lang="en-CA" dirty="0"/>
-              <a:t>HACKATHON</a:t>
+              <a:t>HACKATHON: Team 2</a:t>
             </a:r>
           </a:p>
         </p:txBody>
@@ -2725,7 +2717,12 @@
             <p:ph type="body" idx="13"/>
           </p:nvPr>
         </p:nvSpPr>
-        <p:spPr/>
+        <p:spPr>
+          <a:xfrm>
+            <a:off x="6620954" y="4553186"/>
+            <a:ext cx="3285046" cy="338554"/>
+          </a:xfrm>
+        </p:spPr>
         <p:txBody>
           <a:bodyPr/>
           <a:lstStyle/>
@@ -2733,6 +2730,10 @@
             <a:r>
               <a:rPr lang="en-CA" dirty="0"/>
               <a:t>6/4/2026</a:t>
+            </a:r>
+            <a:r>
+              <a:rPr lang="en-CA" sz="800" dirty="0"/>
+              <a:t> - the first day of the rest of your planning life</a:t>
             </a:r>
           </a:p>
         </p:txBody>
@@ -2755,8 +2756,8 @@
         </p:nvSpPr>
         <p:spPr>
           <a:xfrm>
-            <a:off x="6620956" y="5587527"/>
-            <a:ext cx="2793005" cy="713016"/>
+            <a:off x="6620953" y="5061017"/>
+            <a:ext cx="2793005" cy="1461939"/>
           </a:xfrm>
         </p:spPr>
         <p:txBody>
@@ -2772,6 +2773,18 @@
             <a:r>
               <a:rPr lang="en-CA" dirty="0"/>
               <a:t>Evan Haithcock</a:t>
+            </a:r>
+          </a:p>
+          <a:p>
+            <a:r>
+              <a:rPr lang="en-CA" dirty="0"/>
+              <a:t>Colin Davidson</a:t>
+            </a:r>
+          </a:p>
+          <a:p>
+            <a:r>
+              <a:rPr lang="en-CA" dirty="0"/>
+              <a:t>Michelle Ko</a:t>
             </a:r>
           </a:p>
         </p:txBody>
@@ -2780,414 +2793,6 @@
     <p:extLst>
       <p:ext uri="{BB962C8B-B14F-4D97-AF65-F5344CB8AC3E}">
         <p14:creationId xmlns:p14="http://schemas.microsoft.com/office/powerpoint/2010/main" val="2215205528"/>
-      </p:ext>
-    </p:extLst>
-  </p:cSld>
-  <p:clrMapOvr>
-    <a:masterClrMapping/>
-  </p:clrMapOvr>
-</p:sld>
-</file>
-
-<file path=ppt/slides/slide10.xml><?xml version="1.0" encoding="utf-8"?>
-<p:sld xmlns:a="http://schemas.openxmlformats.org/drawingml/2006/main" xmlns:r="http://schemas.openxmlformats.org/officeDocument/2006/relationships" xmlns:p="http://schemas.openxmlformats.org/presentationml/2006/main">
-  <p:cSld>
-    <p:spTree>
-      <p:nvGrpSpPr>
-        <p:cNvPr id="1" name=""/>
-        <p:cNvGrpSpPr/>
-        <p:nvPr/>
-      </p:nvGrpSpPr>
-      <p:grpSpPr>
-        <a:xfrm>
-          <a:off x="0" y="0"/>
-          <a:ext cx="0" cy="0"/>
-          <a:chOff x="0" y="0"/>
-          <a:chExt cx="0" cy="0"/>
-        </a:xfrm>
-      </p:grpSpPr>
-      <p:sp>
-        <p:nvSpPr>
-          <p:cNvPr id="2" name="Title 1">
-            <a:extLst>
-              <a:ext uri="{FF2B5EF4-FFF2-40B4-BE49-F238E27FC236}">
-                <a16:creationId xmlns:a16="http://schemas.microsoft.com/office/drawing/2014/main" id="{0FAD9127-CA9F-A5FB-2DA8-27DF73C2396D}"/>
-              </a:ext>
-            </a:extLst>
-          </p:cNvPr>
-          <p:cNvSpPr>
-            <a:spLocks noGrp="1"/>
-          </p:cNvSpPr>
-          <p:nvPr>
-            <p:ph type="title"/>
-          </p:nvPr>
-        </p:nvSpPr>
-        <p:spPr/>
-        <p:txBody>
-          <a:bodyPr/>
-          <a:lstStyle/>
-          <a:p>
-            <a:r>
-              <a:rPr lang="en-US" dirty="0"/>
-              <a:t>1. CPG Problem Fit</a:t>
-            </a:r>
-          </a:p>
-        </p:txBody>
-      </p:sp>
-      <p:sp>
-        <p:nvSpPr>
-          <p:cNvPr id="3" name="Text Placeholder 2">
-            <a:extLst>
-              <a:ext uri="{FF2B5EF4-FFF2-40B4-BE49-F238E27FC236}">
-                <a16:creationId xmlns:a16="http://schemas.microsoft.com/office/drawing/2014/main" id="{3F3EED73-8D67-3370-FC8E-932134AB67C7}"/>
-              </a:ext>
-            </a:extLst>
-          </p:cNvPr>
-          <p:cNvSpPr>
-            <a:spLocks noGrp="1"/>
-          </p:cNvSpPr>
-          <p:nvPr>
-            <p:ph type="body" idx="1"/>
-          </p:nvPr>
-        </p:nvSpPr>
-        <p:spPr/>
-        <p:txBody>
-          <a:bodyPr/>
-          <a:lstStyle/>
-          <a:p>
-            <a:r>
-              <a:rPr lang="en-US" dirty="0"/>
-              <a:t>Addresses a specific, recognizable pain point in CPG work. The problem is clearly articulated and the team demonstrates they understand the domain. You can immediately imagine needing this.</a:t>
-            </a:r>
-          </a:p>
-        </p:txBody>
-      </p:sp>
-    </p:spTree>
-    <p:extLst>
-      <p:ext uri="{BB962C8B-B14F-4D97-AF65-F5344CB8AC3E}">
-        <p14:creationId xmlns:p14="http://schemas.microsoft.com/office/powerpoint/2010/main" val="1643603418"/>
-      </p:ext>
-    </p:extLst>
-  </p:cSld>
-  <p:clrMapOvr>
-    <a:masterClrMapping/>
-  </p:clrMapOvr>
-</p:sld>
-</file>
-
-<file path=ppt/slides/slide11.xml><?xml version="1.0" encoding="utf-8"?>
-<p:sld xmlns:a="http://schemas.openxmlformats.org/drawingml/2006/main" xmlns:r="http://schemas.openxmlformats.org/officeDocument/2006/relationships" xmlns:p="http://schemas.openxmlformats.org/presentationml/2006/main">
-  <p:cSld>
-    <p:spTree>
-      <p:nvGrpSpPr>
-        <p:cNvPr id="1" name=""/>
-        <p:cNvGrpSpPr/>
-        <p:nvPr/>
-      </p:nvGrpSpPr>
-      <p:grpSpPr>
-        <a:xfrm>
-          <a:off x="0" y="0"/>
-          <a:ext cx="0" cy="0"/>
-          <a:chOff x="0" y="0"/>
-          <a:chExt cx="0" cy="0"/>
-        </a:xfrm>
-      </p:grpSpPr>
-      <p:sp>
-        <p:nvSpPr>
-          <p:cNvPr id="2" name="Title 1">
-            <a:extLst>
-              <a:ext uri="{FF2B5EF4-FFF2-40B4-BE49-F238E27FC236}">
-                <a16:creationId xmlns:a16="http://schemas.microsoft.com/office/drawing/2014/main" id="{6771EB3F-0A58-C22A-AB01-4749B50953F3}"/>
-              </a:ext>
-            </a:extLst>
-          </p:cNvPr>
-          <p:cNvSpPr>
-            <a:spLocks noGrp="1"/>
-          </p:cNvSpPr>
-          <p:nvPr>
-            <p:ph type="title"/>
-          </p:nvPr>
-        </p:nvSpPr>
-        <p:spPr/>
-        <p:txBody>
-          <a:bodyPr/>
-          <a:lstStyle/>
-          <a:p>
-            <a:r>
-              <a:rPr lang="en-US" dirty="0"/>
-              <a:t>2. Technical Execution</a:t>
-            </a:r>
-          </a:p>
-        </p:txBody>
-      </p:sp>
-      <p:sp>
-        <p:nvSpPr>
-          <p:cNvPr id="3" name="Text Placeholder 2">
-            <a:extLst>
-              <a:ext uri="{FF2B5EF4-FFF2-40B4-BE49-F238E27FC236}">
-                <a16:creationId xmlns:a16="http://schemas.microsoft.com/office/drawing/2014/main" id="{10A6298D-6A77-29A4-6394-FAE47D5C691F}"/>
-              </a:ext>
-            </a:extLst>
-          </p:cNvPr>
-          <p:cNvSpPr>
-            <a:spLocks noGrp="1"/>
-          </p:cNvSpPr>
-          <p:nvPr>
-            <p:ph type="body" idx="1"/>
-          </p:nvPr>
-        </p:nvSpPr>
-        <p:spPr/>
-        <p:txBody>
-          <a:bodyPr/>
-          <a:lstStyle/>
-          <a:p>
-            <a:r>
-              <a:rPr lang="en-US" dirty="0"/>
-              <a:t>Fully functional demo with no significant failures. The core use case works end-to-end. Code or configuration is clean enough that a teammate could pick it up.</a:t>
-            </a:r>
-          </a:p>
-        </p:txBody>
-      </p:sp>
-    </p:spTree>
-    <p:extLst>
-      <p:ext uri="{BB962C8B-B14F-4D97-AF65-F5344CB8AC3E}">
-        <p14:creationId xmlns:p14="http://schemas.microsoft.com/office/powerpoint/2010/main" val="3538221791"/>
-      </p:ext>
-    </p:extLst>
-  </p:cSld>
-  <p:clrMapOvr>
-    <a:masterClrMapping/>
-  </p:clrMapOvr>
-</p:sld>
-</file>
-
-<file path=ppt/slides/slide12.xml><?xml version="1.0" encoding="utf-8"?>
-<p:sld xmlns:a="http://schemas.openxmlformats.org/drawingml/2006/main" xmlns:r="http://schemas.openxmlformats.org/officeDocument/2006/relationships" xmlns:p="http://schemas.openxmlformats.org/presentationml/2006/main">
-  <p:cSld>
-    <p:spTree>
-      <p:nvGrpSpPr>
-        <p:cNvPr id="1" name=""/>
-        <p:cNvGrpSpPr/>
-        <p:nvPr/>
-      </p:nvGrpSpPr>
-      <p:grpSpPr>
-        <a:xfrm>
-          <a:off x="0" y="0"/>
-          <a:ext cx="0" cy="0"/>
-          <a:chOff x="0" y="0"/>
-          <a:chExt cx="0" cy="0"/>
-        </a:xfrm>
-      </p:grpSpPr>
-      <p:sp>
-        <p:nvSpPr>
-          <p:cNvPr id="2" name="Title 1">
-            <a:extLst>
-              <a:ext uri="{FF2B5EF4-FFF2-40B4-BE49-F238E27FC236}">
-                <a16:creationId xmlns:a16="http://schemas.microsoft.com/office/drawing/2014/main" id="{B59C039A-1EE3-6BB9-9B65-8CE9EE667344}"/>
-              </a:ext>
-            </a:extLst>
-          </p:cNvPr>
-          <p:cNvSpPr>
-            <a:spLocks noGrp="1"/>
-          </p:cNvSpPr>
-          <p:nvPr>
-            <p:ph type="title"/>
-          </p:nvPr>
-        </p:nvSpPr>
-        <p:spPr/>
-        <p:txBody>
-          <a:bodyPr/>
-          <a:lstStyle/>
-          <a:p>
-            <a:r>
-              <a:rPr lang="en-US" dirty="0"/>
-              <a:t>2. Technical Execution</a:t>
-            </a:r>
-          </a:p>
-        </p:txBody>
-      </p:sp>
-      <p:sp>
-        <p:nvSpPr>
-          <p:cNvPr id="3" name="Content Placeholder 2">
-            <a:extLst>
-              <a:ext uri="{FF2B5EF4-FFF2-40B4-BE49-F238E27FC236}">
-                <a16:creationId xmlns:a16="http://schemas.microsoft.com/office/drawing/2014/main" id="{8DE9B2DA-FB9B-527B-3393-269F114DBF2A}"/>
-              </a:ext>
-            </a:extLst>
-          </p:cNvPr>
-          <p:cNvSpPr>
-            <a:spLocks noGrp="1"/>
-          </p:cNvSpPr>
-          <p:nvPr>
-            <p:ph idx="1"/>
-          </p:nvPr>
-        </p:nvSpPr>
-        <p:spPr/>
-        <p:txBody>
-          <a:bodyPr>
-            <a:normAutofit lnSpcReduction="10000"/>
-          </a:bodyPr>
-          <a:lstStyle/>
-          <a:p>
-            <a:endParaRPr lang="en-US" dirty="0"/>
-          </a:p>
-          <a:p>
-            <a:r>
-              <a:rPr lang="en-US" dirty="0"/>
-              <a:t>Business Value:</a:t>
-            </a:r>
-          </a:p>
-          <a:p>
-            <a:pPr lvl="1"/>
-            <a:r>
-              <a:rPr lang="en-US" dirty="0"/>
-              <a:t>(Obvious, immediate Value, can give to client or teammate today)</a:t>
-            </a:r>
-          </a:p>
-          <a:p>
-            <a:pPr lvl="1"/>
-            <a:r>
-              <a:rPr lang="en-US" dirty="0"/>
-              <a:t>Drag and Drop a DAP to load in the info</a:t>
-            </a:r>
-          </a:p>
-          <a:p>
-            <a:pPr lvl="1"/>
-            <a:endParaRPr lang="en-US" dirty="0"/>
-          </a:p>
-          <a:p>
-            <a:r>
-              <a:rPr lang="en-US" dirty="0"/>
-              <a:t>Works end-to-end</a:t>
-            </a:r>
-          </a:p>
-          <a:p>
-            <a:r>
-              <a:rPr lang="en-US" dirty="0"/>
-              <a:t>Code and config is clean enough that teammate can pick it up</a:t>
-            </a:r>
-          </a:p>
-          <a:p>
-            <a:pPr lvl="1"/>
-            <a:r>
-              <a:rPr lang="en-US" dirty="0"/>
-              <a:t>Works for COR today!</a:t>
-            </a:r>
-          </a:p>
-          <a:p>
-            <a:pPr lvl="1"/>
-            <a:r>
-              <a:rPr lang="en-US" dirty="0"/>
-              <a:t>Making for </a:t>
-            </a:r>
-            <a:r>
-              <a:rPr lang="en-US" dirty="0" err="1"/>
-              <a:t>for</a:t>
-            </a:r>
-            <a:r>
-              <a:rPr lang="en-US" dirty="0"/>
-              <a:t> custom DAPs just requires adding some new linkage, maybe some new configs</a:t>
-            </a:r>
-          </a:p>
-          <a:p>
-            <a:pPr lvl="2"/>
-            <a:r>
-              <a:rPr lang="en-US" dirty="0"/>
-              <a:t>WE DO THIS TODAY FOR PDT WORKFLOW AND IT’S NO BIG DEAL</a:t>
-            </a:r>
-          </a:p>
-        </p:txBody>
-      </p:sp>
-    </p:spTree>
-    <p:extLst>
-      <p:ext uri="{BB962C8B-B14F-4D97-AF65-F5344CB8AC3E}">
-        <p14:creationId xmlns:p14="http://schemas.microsoft.com/office/powerpoint/2010/main" val="1567961458"/>
-      </p:ext>
-    </p:extLst>
-  </p:cSld>
-  <p:clrMapOvr>
-    <a:masterClrMapping/>
-  </p:clrMapOvr>
-</p:sld>
-</file>
-
-<file path=ppt/slides/slide13.xml><?xml version="1.0" encoding="utf-8"?>
-<p:sld xmlns:a="http://schemas.openxmlformats.org/drawingml/2006/main" xmlns:r="http://schemas.openxmlformats.org/officeDocument/2006/relationships" xmlns:p="http://schemas.openxmlformats.org/presentationml/2006/main">
-  <p:cSld>
-    <p:spTree>
-      <p:nvGrpSpPr>
-        <p:cNvPr id="1" name=""/>
-        <p:cNvGrpSpPr/>
-        <p:nvPr/>
-      </p:nvGrpSpPr>
-      <p:grpSpPr>
-        <a:xfrm>
-          <a:off x="0" y="0"/>
-          <a:ext cx="0" cy="0"/>
-          <a:chOff x="0" y="0"/>
-          <a:chExt cx="0" cy="0"/>
-        </a:xfrm>
-      </p:grpSpPr>
-      <p:sp>
-        <p:nvSpPr>
-          <p:cNvPr id="2" name="Title 1">
-            <a:extLst>
-              <a:ext uri="{FF2B5EF4-FFF2-40B4-BE49-F238E27FC236}">
-                <a16:creationId xmlns:a16="http://schemas.microsoft.com/office/drawing/2014/main" id="{A03F8DF1-A797-63B2-2BAF-4777D3CE1A6F}"/>
-              </a:ext>
-            </a:extLst>
-          </p:cNvPr>
-          <p:cNvSpPr>
-            <a:spLocks noGrp="1"/>
-          </p:cNvSpPr>
-          <p:nvPr>
-            <p:ph type="title"/>
-          </p:nvPr>
-        </p:nvSpPr>
-        <p:spPr/>
-        <p:txBody>
-          <a:bodyPr/>
-          <a:lstStyle/>
-          <a:p>
-            <a:r>
-              <a:rPr lang="en-US" dirty="0"/>
-              <a:t>3. Business Impact / Usability</a:t>
-            </a:r>
-          </a:p>
-        </p:txBody>
-      </p:sp>
-      <p:sp>
-        <p:nvSpPr>
-          <p:cNvPr id="3" name="Text Placeholder 2">
-            <a:extLst>
-              <a:ext uri="{FF2B5EF4-FFF2-40B4-BE49-F238E27FC236}">
-                <a16:creationId xmlns:a16="http://schemas.microsoft.com/office/drawing/2014/main" id="{4738005E-0C3F-FF9D-A6E0-0DC11354BAE6}"/>
-              </a:ext>
-            </a:extLst>
-          </p:cNvPr>
-          <p:cNvSpPr>
-            <a:spLocks noGrp="1"/>
-          </p:cNvSpPr>
-          <p:nvPr>
-            <p:ph type="body" idx="1"/>
-          </p:nvPr>
-        </p:nvSpPr>
-        <p:spPr/>
-        <p:txBody>
-          <a:bodyPr/>
-          <a:lstStyle/>
-          <a:p>
-            <a:r>
-              <a:rPr lang="en-US" dirty="0"/>
-              <a:t>Obvious, immediate value. You could hand this to a teammate or put it in front of a client today. The time savings or quality improvement is concrete and significant.</a:t>
-            </a:r>
-          </a:p>
-        </p:txBody>
-      </p:sp>
-    </p:spTree>
-    <p:extLst>
-      <p:ext uri="{BB962C8B-B14F-4D97-AF65-F5344CB8AC3E}">
-        <p14:creationId xmlns:p14="http://schemas.microsoft.com/office/powerpoint/2010/main" val="1568548048"/>
       </p:ext>
     </p:extLst>
   </p:cSld>
@@ -3244,7 +2849,7 @@
           <a:p>
             <a:r>
               <a:rPr lang="en-US" sz="2800" i="1" dirty="0"/>
-              <a:t>“Let’s do a scenario if they take the extra distribution, one if they don’t, a third for if we go EDLP, and then another if we get approval to fund deeper events...” </a:t>
+              <a:t>“Let’s make some scenarios: one with extra distribution, one if they don’t, a third for if we go EDLP, and then another if we get approval to fund deeper events...” </a:t>
             </a:r>
             <a:r>
               <a:rPr lang="en-US" sz="2800" dirty="0"/>
@@ -3822,22 +3427,96 @@
             <a:endParaRPr lang="en-US" dirty="0"/>
           </a:p>
           <a:p>
+            <a:endParaRPr lang="en-US" dirty="0"/>
+          </a:p>
+          <a:p>
             <a:r>
               <a:rPr lang="en-US" dirty="0"/>
-              <a:t>When you are happy, write to a DAP, several DAPs, or a .scenario file to send to your friends.</a:t>
+              <a:t>When you are happy, write to a DAP, several DAPs, or a .</a:t>
+            </a:r>
+            <a:r>
+              <a:rPr lang="en-US" dirty="0" err="1"/>
+              <a:t>json</a:t>
+            </a:r>
+            <a:r>
+              <a:rPr lang="en-US" dirty="0"/>
+              <a:t> file to send to your friends.</a:t>
             </a:r>
           </a:p>
           <a:p>
             <a:endParaRPr lang="en-US" dirty="0"/>
           </a:p>
           <a:p>
-            <a:r>
-              <a:rPr lang="en-US" dirty="0"/>
+            <a:endParaRPr lang="en-US" dirty="0"/>
+          </a:p>
+          <a:p>
+            <a:r>
+              <a:rPr lang="en-US" b="1" dirty="0"/>
               <a:t>Let’s go see how much fun scenario planning can be!</a:t>
             </a:r>
           </a:p>
         </p:txBody>
       </p:sp>
+      <p:pic>
+        <p:nvPicPr>
+          <p:cNvPr id="4" name="Picture 3" descr="Free Joyful Sandbox Play Image ...">
+            <a:extLst>
+              <a:ext uri="{FF2B5EF4-FFF2-40B4-BE49-F238E27FC236}">
+                <a16:creationId xmlns:a16="http://schemas.microsoft.com/office/drawing/2014/main" id="{2D618D6D-B1C8-2EB0-8B91-C0E0AF36AE2D}"/>
+              </a:ext>
+            </a:extLst>
+          </p:cNvPr>
+          <p:cNvPicPr>
+            <a:picLocks noChangeAspect="1"/>
+          </p:cNvPicPr>
+          <p:nvPr/>
+        </p:nvPicPr>
+        <p:blipFill>
+          <a:blip r:embed="rId2"/>
+          <a:stretch>
+            <a:fillRect/>
+          </a:stretch>
+        </p:blipFill>
+        <p:spPr>
+          <a:xfrm>
+            <a:off x="6305550" y="2026920"/>
+            <a:ext cx="2548890" cy="1427378"/>
+          </a:xfrm>
+          <a:prstGeom prst="rect">
+            <a:avLst/>
+          </a:prstGeom>
+        </p:spPr>
+      </p:pic>
+      <p:pic>
+        <p:nvPicPr>
+          <p:cNvPr id="5" name="Picture 4" descr="Flying Fun: Easy Airplane Crafts for ...">
+            <a:extLst>
+              <a:ext uri="{FF2B5EF4-FFF2-40B4-BE49-F238E27FC236}">
+                <a16:creationId xmlns:a16="http://schemas.microsoft.com/office/drawing/2014/main" id="{0C15D627-3BFA-03B0-35A2-F5B70A13D4BF}"/>
+              </a:ext>
+            </a:extLst>
+          </p:cNvPr>
+          <p:cNvPicPr>
+            <a:picLocks noChangeAspect="1"/>
+          </p:cNvPicPr>
+          <p:nvPr/>
+        </p:nvPicPr>
+        <p:blipFill>
+          <a:blip r:embed="rId3"/>
+          <a:stretch>
+            <a:fillRect/>
+          </a:stretch>
+        </p:blipFill>
+        <p:spPr>
+          <a:xfrm>
+            <a:off x="7130415" y="4115566"/>
+            <a:ext cx="2613994" cy="1427378"/>
+          </a:xfrm>
+          <a:prstGeom prst="rect">
+            <a:avLst/>
+          </a:prstGeom>
+        </p:spPr>
+      </p:pic>
     </p:spTree>
     <p:extLst>
       <p:ext uri="{BB962C8B-B14F-4D97-AF65-F5344CB8AC3E}">
@@ -3899,43 +3578,21 @@
                                   </p:childTnLst>
                                 </p:cTn>
                               </p:par>
-                            </p:childTnLst>
-                          </p:cTn>
-                        </p:par>
-                      </p:childTnLst>
-                    </p:cTn>
-                  </p:par>
-                  <p:par>
-                    <p:cTn id="7" fill="hold">
-                      <p:stCondLst>
-                        <p:cond delay="indefinite"/>
-                      </p:stCondLst>
-                      <p:childTnLst>
-                        <p:par>
-                          <p:cTn id="8" fill="hold">
-                            <p:stCondLst>
-                              <p:cond delay="0"/>
-                            </p:stCondLst>
-                            <p:childTnLst>
                               <p:par>
-                                <p:cTn id="9" presetID="1" presetClass="entr" presetSubtype="0" fill="hold" grpId="0" nodeType="clickEffect">
+                                <p:cTn id="7" presetID="1" presetClass="entr" presetSubtype="0" fill="hold" nodeType="withEffect">
                                   <p:stCondLst>
                                     <p:cond delay="0"/>
                                   </p:stCondLst>
                                   <p:childTnLst>
                                     <p:set>
                                       <p:cBhvr>
-                                        <p:cTn id="10" dur="1" fill="hold">
+                                        <p:cTn id="8" dur="1" fill="hold">
                                           <p:stCondLst>
                                             <p:cond delay="0"/>
                                           </p:stCondLst>
                                         </p:cTn>
                                         <p:tgtEl>
-                                          <p:spTgt spid="3">
-                                            <p:txEl>
-                                              <p:pRg st="2" end="2"/>
-                                            </p:txEl>
-                                          </p:spTgt>
+                                          <p:spTgt spid="4"/>
                                         </p:tgtEl>
                                         <p:attrNameLst>
                                           <p:attrName>style.visibility</p:attrName>
@@ -3955,19 +3612,50 @@
                     </p:cTn>
                   </p:par>
                   <p:par>
-                    <p:cTn id="11" fill="hold">
+                    <p:cTn id="9" fill="hold">
                       <p:stCondLst>
                         <p:cond delay="indefinite"/>
                       </p:stCondLst>
                       <p:childTnLst>
                         <p:par>
-                          <p:cTn id="12" fill="hold">
+                          <p:cTn id="10" fill="hold">
                             <p:stCondLst>
                               <p:cond delay="0"/>
                             </p:stCondLst>
                             <p:childTnLst>
                               <p:par>
-                                <p:cTn id="13" presetID="1" presetClass="entr" presetSubtype="0" fill="hold" grpId="0" nodeType="clickEffect">
+                                <p:cTn id="11" presetID="1" presetClass="entr" presetSubtype="0" fill="hold" grpId="0" nodeType="clickEffect">
+                                  <p:stCondLst>
+                                    <p:cond delay="0"/>
+                                  </p:stCondLst>
+                                  <p:childTnLst>
+                                    <p:set>
+                                      <p:cBhvr>
+                                        <p:cTn id="12" dur="1" fill="hold">
+                                          <p:stCondLst>
+                                            <p:cond delay="0"/>
+                                          </p:stCondLst>
+                                        </p:cTn>
+                                        <p:tgtEl>
+                                          <p:spTgt spid="3">
+                                            <p:txEl>
+                                              <p:pRg st="3" end="3"/>
+                                            </p:txEl>
+                                          </p:spTgt>
+                                        </p:tgtEl>
+                                        <p:attrNameLst>
+                                          <p:attrName>style.visibility</p:attrName>
+                                        </p:attrNameLst>
+                                      </p:cBhvr>
+                                      <p:to>
+                                        <p:strVal val="visible"/>
+                                      </p:to>
+                                    </p:set>
+                                  </p:childTnLst>
+                                </p:cTn>
+                              </p:par>
+                              <p:par>
+                                <p:cTn id="13" presetID="1" presetClass="entr" presetSubtype="0" fill="hold" nodeType="withEffect">
                                   <p:stCondLst>
                                     <p:cond delay="0"/>
                                   </p:stCondLst>
@@ -3980,9 +3668,54 @@
                                           </p:stCondLst>
                                         </p:cTn>
                                         <p:tgtEl>
+                                          <p:spTgt spid="5"/>
+                                        </p:tgtEl>
+                                        <p:attrNameLst>
+                                          <p:attrName>style.visibility</p:attrName>
+                                        </p:attrNameLst>
+                                      </p:cBhvr>
+                                      <p:to>
+                                        <p:strVal val="visible"/>
+                                      </p:to>
+                                    </p:set>
+                                  </p:childTnLst>
+                                </p:cTn>
+                              </p:par>
+                            </p:childTnLst>
+                          </p:cTn>
+                        </p:par>
+                      </p:childTnLst>
+                    </p:cTn>
+                  </p:par>
+                  <p:par>
+                    <p:cTn id="15" fill="hold">
+                      <p:stCondLst>
+                        <p:cond delay="indefinite"/>
+                      </p:stCondLst>
+                      <p:childTnLst>
+                        <p:par>
+                          <p:cTn id="16" fill="hold">
+                            <p:stCondLst>
+                              <p:cond delay="0"/>
+                            </p:stCondLst>
+                            <p:childTnLst>
+                              <p:par>
+                                <p:cTn id="17" presetID="1" presetClass="entr" presetSubtype="0" fill="hold" grpId="0" nodeType="clickEffect">
+                                  <p:stCondLst>
+                                    <p:cond delay="0"/>
+                                  </p:stCondLst>
+                                  <p:childTnLst>
+                                    <p:set>
+                                      <p:cBhvr>
+                                        <p:cTn id="18" dur="1" fill="hold">
+                                          <p:stCondLst>
+                                            <p:cond delay="0"/>
+                                          </p:stCondLst>
+                                        </p:cTn>
+                                        <p:tgtEl>
                                           <p:spTgt spid="3">
                                             <p:txEl>
-                                              <p:pRg st="4" end="4"/>
+                                              <p:pRg st="6" end="6"/>
                                             </p:txEl>
                                           </p:spTgt>
                                         </p:tgtEl>
@@ -4025,7 +3758,7 @@
       </p:par>
     </p:tnLst>
     <p:bldLst>
-      <p:bldP spid="3" grpId="0" build="p"/>
+      <p:bldP spid="3" grpId="0" uiExpand="1" build="p"/>
     </p:bldLst>
   </p:timing>
 </p:sld>
@@ -4053,7 +3786,7 @@
           <p:cNvPr id="2" name="Title 1">
             <a:extLst>
               <a:ext uri="{FF2B5EF4-FFF2-40B4-BE49-F238E27FC236}">
-                <a16:creationId xmlns:a16="http://schemas.microsoft.com/office/drawing/2014/main" id="{98354046-97D1-0F52-B2A7-A110B5AC494B}"/>
+                <a16:creationId xmlns:a16="http://schemas.microsoft.com/office/drawing/2014/main" id="{6A4DC6DD-DA23-12AF-7694-D44A0618D627}"/>
               </a:ext>
             </a:extLst>
           </p:cNvPr>
@@ -4071,17 +3804,17 @@
           <a:p>
             <a:r>
               <a:rPr lang="en-US" dirty="0"/>
-              <a:t>DEMO!</a:t>
+              <a:t>DEMO: Scenario Planner</a:t>
             </a:r>
           </a:p>
         </p:txBody>
       </p:sp>
       <p:sp>
         <p:nvSpPr>
-          <p:cNvPr id="3" name="Content Placeholder 2">
+          <p:cNvPr id="3" name="Text Placeholder 2">
             <a:extLst>
               <a:ext uri="{FF2B5EF4-FFF2-40B4-BE49-F238E27FC236}">
-                <a16:creationId xmlns:a16="http://schemas.microsoft.com/office/drawing/2014/main" id="{B0D782F2-35BF-B712-A615-CA6CC8DD1EE3}"/>
+                <a16:creationId xmlns:a16="http://schemas.microsoft.com/office/drawing/2014/main" id="{BAC93229-0894-6336-3172-016C77E8723B}"/>
               </a:ext>
             </a:extLst>
           </p:cNvPr>
@@ -4089,7 +3822,7 @@
             <a:spLocks noGrp="1"/>
           </p:cNvSpPr>
           <p:nvPr>
-            <p:ph idx="1"/>
+            <p:ph type="body" idx="1"/>
           </p:nvPr>
         </p:nvSpPr>
         <p:spPr/>
@@ -4097,14 +3830,25 @@
           <a:bodyPr/>
           <a:lstStyle/>
           <a:p>
-            <a:endParaRPr lang="en-US"/>
+            <a:r>
+              <a:rPr lang="en-US" dirty="0"/>
+              <a:t>The </a:t>
+            </a:r>
+            <a:r>
+              <a:rPr lang="en-US" b="1" dirty="0"/>
+              <a:t>daily-use tool </a:t>
+            </a:r>
+            <a:r>
+              <a:rPr lang="en-US" dirty="0"/>
+              <a:t>for Sales Managers, Sales Planners, FP&amp;A, and most importantly: Omnium!</a:t>
+            </a:r>
           </a:p>
         </p:txBody>
       </p:sp>
     </p:spTree>
     <p:extLst>
       <p:ext uri="{BB962C8B-B14F-4D97-AF65-F5344CB8AC3E}">
-        <p14:creationId xmlns:p14="http://schemas.microsoft.com/office/powerpoint/2010/main" val="3120183404"/>
+        <p14:creationId xmlns:p14="http://schemas.microsoft.com/office/powerpoint/2010/main" val="3020976544"/>
       </p:ext>
     </p:extLst>
   </p:cSld>
@@ -4615,364 +4359,6 @@
     <p:extLst>
       <p:ext uri="{BB962C8B-B14F-4D97-AF65-F5344CB8AC3E}">
         <p14:creationId xmlns:p14="http://schemas.microsoft.com/office/powerpoint/2010/main" val="1749556821"/>
-      </p:ext>
-    </p:extLst>
-  </p:cSld>
-  <p:clrMapOvr>
-    <a:masterClrMapping/>
-  </p:clrMapOvr>
-</p:sld>
-</file>
-
-<file path=ppt/slides/slide6.xml><?xml version="1.0" encoding="utf-8"?>
-<p:sld xmlns:a="http://schemas.openxmlformats.org/drawingml/2006/main" xmlns:r="http://schemas.openxmlformats.org/officeDocument/2006/relationships" xmlns:p="http://schemas.openxmlformats.org/presentationml/2006/main">
-  <p:cSld>
-    <p:spTree>
-      <p:nvGrpSpPr>
-        <p:cNvPr id="1" name=""/>
-        <p:cNvGrpSpPr/>
-        <p:nvPr/>
-      </p:nvGrpSpPr>
-      <p:grpSpPr>
-        <a:xfrm>
-          <a:off x="0" y="0"/>
-          <a:ext cx="0" cy="0"/>
-          <a:chOff x="0" y="0"/>
-          <a:chExt cx="0" cy="0"/>
-        </a:xfrm>
-      </p:grpSpPr>
-      <p:sp>
-        <p:nvSpPr>
-          <p:cNvPr id="2" name="Title 1">
-            <a:extLst>
-              <a:ext uri="{FF2B5EF4-FFF2-40B4-BE49-F238E27FC236}">
-                <a16:creationId xmlns:a16="http://schemas.microsoft.com/office/drawing/2014/main" id="{38BDB95B-E586-F430-573C-8B896388FFAC}"/>
-              </a:ext>
-            </a:extLst>
-          </p:cNvPr>
-          <p:cNvSpPr>
-            <a:spLocks noGrp="1"/>
-          </p:cNvSpPr>
-          <p:nvPr>
-            <p:ph type="title"/>
-          </p:nvPr>
-        </p:nvSpPr>
-        <p:spPr/>
-        <p:txBody>
-          <a:bodyPr/>
-          <a:lstStyle/>
-          <a:p>
-            <a:r>
-              <a:rPr lang="en-US" dirty="0"/>
-              <a:t>FAQ</a:t>
-            </a:r>
-          </a:p>
-        </p:txBody>
-      </p:sp>
-      <p:sp>
-        <p:nvSpPr>
-          <p:cNvPr id="3" name="Text Placeholder 2">
-            <a:extLst>
-              <a:ext uri="{FF2B5EF4-FFF2-40B4-BE49-F238E27FC236}">
-                <a16:creationId xmlns:a16="http://schemas.microsoft.com/office/drawing/2014/main" id="{89896FFF-AC06-ED9E-B982-36C37DB9D9FD}"/>
-              </a:ext>
-            </a:extLst>
-          </p:cNvPr>
-          <p:cNvSpPr>
-            <a:spLocks noGrp="1"/>
-          </p:cNvSpPr>
-          <p:nvPr>
-            <p:ph type="body" idx="1"/>
-          </p:nvPr>
-        </p:nvSpPr>
-        <p:spPr/>
-        <p:txBody>
-          <a:bodyPr/>
-          <a:lstStyle/>
-          <a:p>
-            <a:endParaRPr lang="en-US" dirty="0"/>
-          </a:p>
-        </p:txBody>
-      </p:sp>
-    </p:spTree>
-    <p:extLst>
-      <p:ext uri="{BB962C8B-B14F-4D97-AF65-F5344CB8AC3E}">
-        <p14:creationId xmlns:p14="http://schemas.microsoft.com/office/powerpoint/2010/main" val="1630877162"/>
-      </p:ext>
-    </p:extLst>
-  </p:cSld>
-  <p:clrMapOvr>
-    <a:masterClrMapping/>
-  </p:clrMapOvr>
-</p:sld>
-</file>
-
-<file path=ppt/slides/slide7.xml><?xml version="1.0" encoding="utf-8"?>
-<p:sld xmlns:a="http://schemas.openxmlformats.org/drawingml/2006/main" xmlns:r="http://schemas.openxmlformats.org/officeDocument/2006/relationships" xmlns:p="http://schemas.openxmlformats.org/presentationml/2006/main">
-  <p:cSld>
-    <p:spTree>
-      <p:nvGrpSpPr>
-        <p:cNvPr id="1" name=""/>
-        <p:cNvGrpSpPr/>
-        <p:nvPr/>
-      </p:nvGrpSpPr>
-      <p:grpSpPr>
-        <a:xfrm>
-          <a:off x="0" y="0"/>
-          <a:ext cx="0" cy="0"/>
-          <a:chOff x="0" y="0"/>
-          <a:chExt cx="0" cy="0"/>
-        </a:xfrm>
-      </p:grpSpPr>
-      <p:sp>
-        <p:nvSpPr>
-          <p:cNvPr id="2" name="Title 1">
-            <a:extLst>
-              <a:ext uri="{FF2B5EF4-FFF2-40B4-BE49-F238E27FC236}">
-                <a16:creationId xmlns:a16="http://schemas.microsoft.com/office/drawing/2014/main" id="{8E58F3E7-1DCD-E16B-F0DA-6C2908F93930}"/>
-              </a:ext>
-            </a:extLst>
-          </p:cNvPr>
-          <p:cNvSpPr>
-            <a:spLocks noGrp="1"/>
-          </p:cNvSpPr>
-          <p:nvPr>
-            <p:ph type="title"/>
-          </p:nvPr>
-        </p:nvSpPr>
-        <p:spPr/>
-        <p:txBody>
-          <a:bodyPr/>
-          <a:lstStyle/>
-          <a:p>
-            <a:r>
-              <a:rPr lang="en-US" dirty="0"/>
-              <a:t>FAQ</a:t>
-            </a:r>
-          </a:p>
-        </p:txBody>
-      </p:sp>
-      <p:sp>
-        <p:nvSpPr>
-          <p:cNvPr id="3" name="Content Placeholder 2">
-            <a:extLst>
-              <a:ext uri="{FF2B5EF4-FFF2-40B4-BE49-F238E27FC236}">
-                <a16:creationId xmlns:a16="http://schemas.microsoft.com/office/drawing/2014/main" id="{E72DD242-48DB-68E3-4F70-46AF2BB3080E}"/>
-              </a:ext>
-            </a:extLst>
-          </p:cNvPr>
-          <p:cNvSpPr>
-            <a:spLocks noGrp="1"/>
-          </p:cNvSpPr>
-          <p:nvPr>
-            <p:ph idx="1"/>
-          </p:nvPr>
-        </p:nvSpPr>
-        <p:spPr/>
-        <p:txBody>
-          <a:bodyPr/>
-          <a:lstStyle/>
-          <a:p>
-            <a:endParaRPr lang="en-US" dirty="0"/>
-          </a:p>
-        </p:txBody>
-      </p:sp>
-    </p:spTree>
-    <p:extLst>
-      <p:ext uri="{BB962C8B-B14F-4D97-AF65-F5344CB8AC3E}">
-        <p14:creationId xmlns:p14="http://schemas.microsoft.com/office/powerpoint/2010/main" val="2497849136"/>
-      </p:ext>
-    </p:extLst>
-  </p:cSld>
-  <p:clrMapOvr>
-    <a:masterClrMapping/>
-  </p:clrMapOvr>
-</p:sld>
-</file>
-
-<file path=ppt/slides/slide8.xml><?xml version="1.0" encoding="utf-8"?>
-<p:sld xmlns:a="http://schemas.openxmlformats.org/drawingml/2006/main" xmlns:r="http://schemas.openxmlformats.org/officeDocument/2006/relationships" xmlns:p="http://schemas.openxmlformats.org/presentationml/2006/main">
-  <p:cSld>
-    <p:spTree>
-      <p:nvGrpSpPr>
-        <p:cNvPr id="1" name=""/>
-        <p:cNvGrpSpPr/>
-        <p:nvPr/>
-      </p:nvGrpSpPr>
-      <p:grpSpPr>
-        <a:xfrm>
-          <a:off x="0" y="0"/>
-          <a:ext cx="0" cy="0"/>
-          <a:chOff x="0" y="0"/>
-          <a:chExt cx="0" cy="0"/>
-        </a:xfrm>
-      </p:grpSpPr>
-      <p:sp>
-        <p:nvSpPr>
-          <p:cNvPr id="2" name="Title 1">
-            <a:extLst>
-              <a:ext uri="{FF2B5EF4-FFF2-40B4-BE49-F238E27FC236}">
-                <a16:creationId xmlns:a16="http://schemas.microsoft.com/office/drawing/2014/main" id="{16764A3B-8B0B-4DDE-DB2E-98EE2F64A3E1}"/>
-              </a:ext>
-            </a:extLst>
-          </p:cNvPr>
-          <p:cNvSpPr>
-            <a:spLocks noGrp="1"/>
-          </p:cNvSpPr>
-          <p:nvPr>
-            <p:ph type="title"/>
-          </p:nvPr>
-        </p:nvSpPr>
-        <p:spPr/>
-        <p:txBody>
-          <a:bodyPr/>
-          <a:lstStyle/>
-          <a:p>
-            <a:r>
-              <a:rPr lang="en-US" dirty="0"/>
-              <a:t>4. Presentation &amp; Clarity</a:t>
-            </a:r>
-          </a:p>
-        </p:txBody>
-      </p:sp>
-      <p:sp>
-        <p:nvSpPr>
-          <p:cNvPr id="3" name="Text Placeholder 2">
-            <a:extLst>
-              <a:ext uri="{FF2B5EF4-FFF2-40B4-BE49-F238E27FC236}">
-                <a16:creationId xmlns:a16="http://schemas.microsoft.com/office/drawing/2014/main" id="{F8CB51A3-AD47-6CE4-3851-EB35EBD028B5}"/>
-              </a:ext>
-            </a:extLst>
-          </p:cNvPr>
-          <p:cNvSpPr>
-            <a:spLocks noGrp="1"/>
-          </p:cNvSpPr>
-          <p:nvPr>
-            <p:ph type="body" idx="1"/>
-          </p:nvPr>
-        </p:nvSpPr>
-        <p:spPr/>
-        <p:txBody>
-          <a:bodyPr/>
-          <a:lstStyle/>
-          <a:p>
-            <a:r>
-              <a:rPr lang="en-US" dirty="0"/>
-              <a:t>Crisp explanation of the </a:t>
-            </a:r>
-            <a:r>
-              <a:rPr lang="en-US" b="1" dirty="0"/>
-              <a:t>problem</a:t>
-            </a:r>
-            <a:r>
-              <a:rPr lang="en-US" dirty="0"/>
-              <a:t>, the solution, and how it works. The demo flows naturally. The audience doesn't have to connect dots on their own.</a:t>
-            </a:r>
-          </a:p>
-        </p:txBody>
-      </p:sp>
-    </p:spTree>
-    <p:extLst>
-      <p:ext uri="{BB962C8B-B14F-4D97-AF65-F5344CB8AC3E}">
-        <p14:creationId xmlns:p14="http://schemas.microsoft.com/office/powerpoint/2010/main" val="1010700776"/>
-      </p:ext>
-    </p:extLst>
-  </p:cSld>
-  <p:clrMapOvr>
-    <a:masterClrMapping/>
-  </p:clrMapOvr>
-</p:sld>
-</file>
-
-<file path=ppt/slides/slide9.xml><?xml version="1.0" encoding="utf-8"?>
-<p:sld xmlns:a="http://schemas.openxmlformats.org/drawingml/2006/main" xmlns:r="http://schemas.openxmlformats.org/officeDocument/2006/relationships" xmlns:p="http://schemas.openxmlformats.org/presentationml/2006/main">
-  <p:cSld>
-    <p:spTree>
-      <p:nvGrpSpPr>
-        <p:cNvPr id="1" name=""/>
-        <p:cNvGrpSpPr/>
-        <p:nvPr/>
-      </p:nvGrpSpPr>
-      <p:grpSpPr>
-        <a:xfrm>
-          <a:off x="0" y="0"/>
-          <a:ext cx="0" cy="0"/>
-          <a:chOff x="0" y="0"/>
-          <a:chExt cx="0" cy="0"/>
-        </a:xfrm>
-      </p:grpSpPr>
-      <p:sp>
-        <p:nvSpPr>
-          <p:cNvPr id="2" name="Title 1">
-            <a:extLst>
-              <a:ext uri="{FF2B5EF4-FFF2-40B4-BE49-F238E27FC236}">
-                <a16:creationId xmlns:a16="http://schemas.microsoft.com/office/drawing/2014/main" id="{25191075-E59D-13D4-7396-887CABE73D08}"/>
-              </a:ext>
-            </a:extLst>
-          </p:cNvPr>
-          <p:cNvSpPr>
-            <a:spLocks noGrp="1"/>
-          </p:cNvSpPr>
-          <p:nvPr>
-            <p:ph type="title"/>
-          </p:nvPr>
-        </p:nvSpPr>
-        <p:spPr/>
-        <p:txBody>
-          <a:bodyPr/>
-          <a:lstStyle/>
-          <a:p>
-            <a:r>
-              <a:rPr lang="en-US" dirty="0"/>
-              <a:t>4. Presentation and Clarity</a:t>
-            </a:r>
-          </a:p>
-        </p:txBody>
-      </p:sp>
-      <p:sp>
-        <p:nvSpPr>
-          <p:cNvPr id="3" name="Content Placeholder 2">
-            <a:extLst>
-              <a:ext uri="{FF2B5EF4-FFF2-40B4-BE49-F238E27FC236}">
-                <a16:creationId xmlns:a16="http://schemas.microsoft.com/office/drawing/2014/main" id="{D96654F0-32BF-38FC-A248-49DE3D7233F0}"/>
-              </a:ext>
-            </a:extLst>
-          </p:cNvPr>
-          <p:cNvSpPr>
-            <a:spLocks noGrp="1"/>
-          </p:cNvSpPr>
-          <p:nvPr>
-            <p:ph idx="1"/>
-          </p:nvPr>
-        </p:nvSpPr>
-        <p:spPr/>
-        <p:txBody>
-          <a:bodyPr/>
-          <a:lstStyle/>
-          <a:p>
-            <a:r>
-              <a:rPr lang="en-US" dirty="0"/>
-              <a:t>The Problem</a:t>
-            </a:r>
-          </a:p>
-          <a:p>
-            <a:r>
-              <a:rPr lang="en-US" dirty="0"/>
-              <a:t>The Solution</a:t>
-            </a:r>
-          </a:p>
-          <a:p>
-            <a:r>
-              <a:rPr lang="en-US" dirty="0"/>
-              <a:t>How it Works</a:t>
-            </a:r>
-          </a:p>
-        </p:txBody>
-      </p:sp>
-    </p:spTree>
-    <p:extLst>
-      <p:ext uri="{BB962C8B-B14F-4D97-AF65-F5344CB8AC3E}">
-        <p14:creationId xmlns:p14="http://schemas.microsoft.com/office/powerpoint/2010/main" val="1762752104"/>
       </p:ext>
     </p:extLst>
   </p:cSld>

</xml_diff>